<commit_message>
Update PPT: embed actual figures from NEWresults218, add model comparison scatter slide
- Replaced all placeholder boxes with actual embedded images from NEWresults218/
- Added new slide 20 with Part 7.7 model comparison scatter plots (03a/03b/03c)
- Slides with single-depot placeholders now show both iWAT and gWAT side by side
- Reviewed Part 7.7 logic: all statistical tests, sample annotations, and DESeq2
  models are correct and internally consistent
- Verified all numbers in results text match PPT data tables

https://claude.ai/code/session_015YYR4p66gPr2btYzUTg3ot
</commit_message>
<xml_diff>
--- a/Results/KAT8_sex_interaction_presentation.pptx
+++ b/Results/KAT8_sex_interaction_presentation.pptx
@@ -26,6 +26,7 @@
     <p:sldId id="274" r:id="rId25"/>
     <p:sldId id="275" r:id="rId26"/>
     <p:sldId id="276" r:id="rId27"/>
+    <p:sldId id="277" r:id="rId28"/>
   </p:sldIdLst>
   <p:sldSz cx="12191695" cy="6858000" type="screen4x3"/>
   <p:notesSz cx="6858000" cy="9144000"/>
@@ -4335,69 +4336,122 @@
           </a:p>
         </p:txBody>
       </p:sp>
-      <p:sp>
-        <p:nvSpPr>
-          <p:cNvPr id="6" name="Rectangle 5"/>
-          <p:cNvSpPr/>
+      <p:pic>
+        <p:nvPicPr>
+          <p:cNvPr id="6" name="Picture 5" descr="04_variance_decomposition_iWAT.png"/>
+          <p:cNvPicPr>
+            <a:picLocks noChangeAspect="1"/>
+          </p:cNvPicPr>
           <p:nvPr/>
-        </p:nvSpPr>
+        </p:nvPicPr>
+        <p:blipFill>
+          <a:blip r:embed="rId2"/>
+          <a:stretch>
+            <a:fillRect/>
+          </a:stretch>
+        </p:blipFill>
         <p:spPr>
           <a:xfrm>
             <a:off x="5943600" y="1371600"/>
-            <a:ext cx="5486400" cy="4572000"/>
+            <a:ext cx="2743200" cy="2286000"/>
           </a:xfrm>
           <a:prstGeom prst="rect">
             <a:avLst/>
           </a:prstGeom>
-          <a:solidFill>
-            <a:srgbClr val="F2F2F2"/>
-          </a:solidFill>
-          <a:ln w="19050">
-            <a:solidFill>
-              <a:srgbClr val="999999"/>
-            </a:solidFill>
-            <a:prstDash val="sysDash"/>
-          </a:ln>
         </p:spPr>
-        <p:style>
-          <a:lnRef idx="1">
-            <a:schemeClr val="accent1"/>
-          </a:lnRef>
-          <a:fillRef idx="3">
-            <a:schemeClr val="accent1"/>
-          </a:fillRef>
-          <a:effectRef idx="2">
-            <a:schemeClr val="accent1"/>
-          </a:effectRef>
-          <a:fontRef idx="minor">
-            <a:schemeClr val="lt1"/>
-          </a:fontRef>
-        </p:style>
-        <p:txBody>
-          <a:bodyPr rtlCol="0" anchor="ctr" wrap="square"/>
+      </p:pic>
+      <p:pic>
+        <p:nvPicPr>
+          <p:cNvPr id="7" name="Picture 6" descr="04_variance_decomposition_gWAT.png"/>
+          <p:cNvPicPr>
+            <a:picLocks noChangeAspect="1"/>
+          </p:cNvPicPr>
+          <p:nvPr/>
+        </p:nvPicPr>
+        <p:blipFill>
+          <a:blip r:embed="rId3"/>
+          <a:stretch>
+            <a:fillRect/>
+          </a:stretch>
+        </p:blipFill>
+        <p:spPr>
+          <a:xfrm>
+            <a:off x="8869680" y="1371600"/>
+            <a:ext cx="2743200" cy="2286000"/>
+          </a:xfrm>
+          <a:prstGeom prst="rect">
+            <a:avLst/>
+          </a:prstGeom>
+        </p:spPr>
+      </p:pic>
+      <p:sp>
+        <p:nvSpPr>
+          <p:cNvPr id="8" name="TextBox 7"/>
+          <p:cNvSpPr txBox="1"/>
+          <p:nvPr/>
+        </p:nvSpPr>
+        <p:spPr>
+          <a:xfrm>
+            <a:off x="6675120" y="3749039"/>
+            <a:ext cx="1828800" cy="274320"/>
+          </a:xfrm>
+          <a:prstGeom prst="rect">
+            <a:avLst/>
+          </a:prstGeom>
+          <a:noFill/>
+        </p:spPr>
+        <p:txBody>
+          <a:bodyPr wrap="square">
+            <a:spAutoFit/>
+          </a:bodyPr>
           <a:lstStyle/>
           <a:p>
             <a:pPr algn="ctr">
-              <a:defRPr sz="1400" b="1">
+              <a:defRPr sz="1100" b="1">
                 <a:solidFill>
                   <a:srgbClr val="666666"/>
                 </a:solidFill>
-              </a:defRPr>
-            </a:pPr>
-            <a:r>
-              <a:t>INSERT PLOT</a:t>
-            </a:r>
-          </a:p>
+                <a:latin typeface="Calibri"/>
+              </a:defRPr>
+            </a:pPr>
+            <a:r>
+              <a:t>iWAT</a:t>
+            </a:r>
+          </a:p>
+        </p:txBody>
+      </p:sp>
+      <p:sp>
+        <p:nvSpPr>
+          <p:cNvPr id="9" name="TextBox 8"/>
+          <p:cNvSpPr txBox="1"/>
+          <p:nvPr/>
+        </p:nvSpPr>
+        <p:spPr>
+          <a:xfrm>
+            <a:off x="9601200" y="3749039"/>
+            <a:ext cx="1828800" cy="274320"/>
+          </a:xfrm>
+          <a:prstGeom prst="rect">
+            <a:avLst/>
+          </a:prstGeom>
+          <a:noFill/>
+        </p:spPr>
+        <p:txBody>
+          <a:bodyPr wrap="square">
+            <a:spAutoFit/>
+          </a:bodyPr>
+          <a:lstStyle/>
           <a:p>
             <a:pPr algn="ctr">
-              <a:defRPr sz="1100" i="1">
+              <a:defRPr sz="1100" b="1">
                 <a:solidFill>
                   <a:srgbClr val="666666"/>
                 </a:solidFill>
-              </a:defRPr>
-            </a:pPr>
-            <a:r>
-              <a:t>variance_explained_&lt;depot&gt;_&lt;run_tag&gt;.png</a:t>
+                <a:latin typeface="Calibri"/>
+              </a:defRPr>
+            </a:pPr>
+            <a:r>
+              <a:t>gWAT</a:t>
             </a:r>
           </a:p>
         </p:txBody>
@@ -5155,12 +5209,20 @@
           </a:p>
         </p:txBody>
       </p:sp>
-      <p:sp>
-        <p:nvSpPr>
-          <p:cNvPr id="5" name="Rectangle 4"/>
-          <p:cNvSpPr/>
+      <p:pic>
+        <p:nvPicPr>
+          <p:cNvPr id="5" name="Picture 4" descr="02_sex_concordance_scatter_iWAT.png"/>
+          <p:cNvPicPr>
+            <a:picLocks noChangeAspect="1"/>
+          </p:cNvPicPr>
           <p:nvPr/>
-        </p:nvSpPr>
+        </p:nvPicPr>
+        <p:blipFill>
+          <a:blip r:embed="rId2"/>
+          <a:stretch>
+            <a:fillRect/>
+          </a:stretch>
+        </p:blipFill>
         <p:spPr>
           <a:xfrm>
             <a:off x="5943600" y="1371600"/>
@@ -5169,59 +5231,8 @@
           <a:prstGeom prst="rect">
             <a:avLst/>
           </a:prstGeom>
-          <a:solidFill>
-            <a:srgbClr val="F2F2F2"/>
-          </a:solidFill>
-          <a:ln w="19050">
-            <a:solidFill>
-              <a:srgbClr val="999999"/>
-            </a:solidFill>
-            <a:prstDash val="sysDash"/>
-          </a:ln>
         </p:spPr>
-        <p:style>
-          <a:lnRef idx="1">
-            <a:schemeClr val="accent1"/>
-          </a:lnRef>
-          <a:fillRef idx="3">
-            <a:schemeClr val="accent1"/>
-          </a:fillRef>
-          <a:effectRef idx="2">
-            <a:schemeClr val="accent1"/>
-          </a:effectRef>
-          <a:fontRef idx="minor">
-            <a:schemeClr val="lt1"/>
-          </a:fontRef>
-        </p:style>
-        <p:txBody>
-          <a:bodyPr rtlCol="0" anchor="ctr" wrap="square"/>
-          <a:lstStyle/>
-          <a:p>
-            <a:pPr algn="ctr">
-              <a:defRPr sz="1400" b="1">
-                <a:solidFill>
-                  <a:srgbClr val="666666"/>
-                </a:solidFill>
-              </a:defRPr>
-            </a:pPr>
-            <a:r>
-              <a:t>INSERT PLOT</a:t>
-            </a:r>
-          </a:p>
-          <a:p>
-            <a:pPr algn="ctr">
-              <a:defRPr sz="1100" i="1">
-                <a:solidFill>
-                  <a:srgbClr val="666666"/>
-                </a:solidFill>
-              </a:defRPr>
-            </a:pPr>
-            <a:r>
-              <a:t>sex_concordance_scatter_iWAT_&lt;run_tag&gt;.png</a:t>
-            </a:r>
-          </a:p>
-        </p:txBody>
-      </p:sp>
+      </p:pic>
     </p:spTree>
   </p:cSld>
   <p:clrMapOvr>
@@ -5598,12 +5609,20 @@
           </a:p>
         </p:txBody>
       </p:sp>
-      <p:sp>
-        <p:nvSpPr>
-          <p:cNvPr id="5" name="Rectangle 4"/>
-          <p:cNvSpPr/>
+      <p:pic>
+        <p:nvPicPr>
+          <p:cNvPr id="5" name="Picture 4" descr="02_sex_concordance_scatter_gWAT.png"/>
+          <p:cNvPicPr>
+            <a:picLocks noChangeAspect="1"/>
+          </p:cNvPicPr>
           <p:nvPr/>
-        </p:nvSpPr>
+        </p:nvPicPr>
+        <p:blipFill>
+          <a:blip r:embed="rId2"/>
+          <a:stretch>
+            <a:fillRect/>
+          </a:stretch>
+        </p:blipFill>
         <p:spPr>
           <a:xfrm>
             <a:off x="5943600" y="1371600"/>
@@ -5612,59 +5631,8 @@
           <a:prstGeom prst="rect">
             <a:avLst/>
           </a:prstGeom>
-          <a:solidFill>
-            <a:srgbClr val="F2F2F2"/>
-          </a:solidFill>
-          <a:ln w="19050">
-            <a:solidFill>
-              <a:srgbClr val="999999"/>
-            </a:solidFill>
-            <a:prstDash val="sysDash"/>
-          </a:ln>
         </p:spPr>
-        <p:style>
-          <a:lnRef idx="1">
-            <a:schemeClr val="accent1"/>
-          </a:lnRef>
-          <a:fillRef idx="3">
-            <a:schemeClr val="accent1"/>
-          </a:fillRef>
-          <a:effectRef idx="2">
-            <a:schemeClr val="accent1"/>
-          </a:effectRef>
-          <a:fontRef idx="minor">
-            <a:schemeClr val="lt1"/>
-          </a:fontRef>
-        </p:style>
-        <p:txBody>
-          <a:bodyPr rtlCol="0" anchor="ctr" wrap="square"/>
-          <a:lstStyle/>
-          <a:p>
-            <a:pPr algn="ctr">
-              <a:defRPr sz="1400" b="1">
-                <a:solidFill>
-                  <a:srgbClr val="666666"/>
-                </a:solidFill>
-              </a:defRPr>
-            </a:pPr>
-            <a:r>
-              <a:t>INSERT PLOT</a:t>
-            </a:r>
-          </a:p>
-          <a:p>
-            <a:pPr algn="ctr">
-              <a:defRPr sz="1100" i="1">
-                <a:solidFill>
-                  <a:srgbClr val="666666"/>
-                </a:solidFill>
-              </a:defRPr>
-            </a:pPr>
-            <a:r>
-              <a:t>sex_concordance_scatter_gWAT_&lt;run_tag&gt;.png</a:t>
-            </a:r>
-          </a:p>
-        </p:txBody>
-      </p:sp>
+      </p:pic>
     </p:spTree>
   </p:cSld>
   <p:clrMapOvr>
@@ -6018,69 +5986,122 @@
           </a:p>
         </p:txBody>
       </p:sp>
-      <p:sp>
-        <p:nvSpPr>
-          <p:cNvPr id="4" name="Rectangle 3"/>
-          <p:cNvSpPr/>
+      <p:pic>
+        <p:nvPicPr>
+          <p:cNvPr id="4" name="Picture 3" descr="05_PCA_by_sex_iWAT.png"/>
+          <p:cNvPicPr>
+            <a:picLocks noChangeAspect="1"/>
+          </p:cNvPicPr>
           <p:nvPr/>
-        </p:nvSpPr>
+        </p:nvPicPr>
+        <p:blipFill>
+          <a:blip r:embed="rId2"/>
+          <a:stretch>
+            <a:fillRect/>
+          </a:stretch>
+        </p:blipFill>
         <p:spPr>
           <a:xfrm>
             <a:off x="5943600" y="1097280"/>
-            <a:ext cx="5486400" cy="4572000"/>
+            <a:ext cx="2926080" cy="2468880"/>
           </a:xfrm>
           <a:prstGeom prst="rect">
             <a:avLst/>
           </a:prstGeom>
-          <a:solidFill>
-            <a:srgbClr val="F2F2F2"/>
-          </a:solidFill>
-          <a:ln w="19050">
-            <a:solidFill>
-              <a:srgbClr val="999999"/>
-            </a:solidFill>
-            <a:prstDash val="sysDash"/>
-          </a:ln>
         </p:spPr>
-        <p:style>
-          <a:lnRef idx="1">
-            <a:schemeClr val="accent1"/>
-          </a:lnRef>
-          <a:fillRef idx="3">
-            <a:schemeClr val="accent1"/>
-          </a:fillRef>
-          <a:effectRef idx="2">
-            <a:schemeClr val="accent1"/>
-          </a:effectRef>
-          <a:fontRef idx="minor">
-            <a:schemeClr val="lt1"/>
-          </a:fontRef>
-        </p:style>
-        <p:txBody>
-          <a:bodyPr rtlCol="0" anchor="ctr" wrap="square"/>
+      </p:pic>
+      <p:pic>
+        <p:nvPicPr>
+          <p:cNvPr id="5" name="Picture 4" descr="05_PCA_by_sex_gWAT.png"/>
+          <p:cNvPicPr>
+            <a:picLocks noChangeAspect="1"/>
+          </p:cNvPicPr>
+          <p:nvPr/>
+        </p:nvPicPr>
+        <p:blipFill>
+          <a:blip r:embed="rId3"/>
+          <a:stretch>
+            <a:fillRect/>
+          </a:stretch>
+        </p:blipFill>
+        <p:spPr>
+          <a:xfrm>
+            <a:off x="8961120" y="1097280"/>
+            <a:ext cx="2926080" cy="2468880"/>
+          </a:xfrm>
+          <a:prstGeom prst="rect">
+            <a:avLst/>
+          </a:prstGeom>
+        </p:spPr>
+      </p:pic>
+      <p:sp>
+        <p:nvSpPr>
+          <p:cNvPr id="6" name="TextBox 5"/>
+          <p:cNvSpPr txBox="1"/>
+          <p:nvPr/>
+        </p:nvSpPr>
+        <p:spPr>
+          <a:xfrm>
+            <a:off x="6217920" y="3657600"/>
+            <a:ext cx="2286000" cy="274320"/>
+          </a:xfrm>
+          <a:prstGeom prst="rect">
+            <a:avLst/>
+          </a:prstGeom>
+          <a:noFill/>
+        </p:spPr>
+        <p:txBody>
+          <a:bodyPr wrap="square">
+            <a:spAutoFit/>
+          </a:bodyPr>
           <a:lstStyle/>
           <a:p>
             <a:pPr algn="ctr">
-              <a:defRPr sz="1400" b="1">
+              <a:defRPr sz="1100" b="1">
                 <a:solidFill>
                   <a:srgbClr val="666666"/>
                 </a:solidFill>
-              </a:defRPr>
-            </a:pPr>
-            <a:r>
-              <a:t>INSERT PLOT</a:t>
-            </a:r>
-          </a:p>
+                <a:latin typeface="Calibri"/>
+              </a:defRPr>
+            </a:pPr>
+            <a:r>
+              <a:t>iWAT</a:t>
+            </a:r>
+          </a:p>
+        </p:txBody>
+      </p:sp>
+      <p:sp>
+        <p:nvSpPr>
+          <p:cNvPr id="7" name="TextBox 6"/>
+          <p:cNvSpPr txBox="1"/>
+          <p:nvPr/>
+        </p:nvSpPr>
+        <p:spPr>
+          <a:xfrm>
+            <a:off x="9235440" y="3657600"/>
+            <a:ext cx="2286000" cy="274320"/>
+          </a:xfrm>
+          <a:prstGeom prst="rect">
+            <a:avLst/>
+          </a:prstGeom>
+          <a:noFill/>
+        </p:spPr>
+        <p:txBody>
+          <a:bodyPr wrap="square">
+            <a:spAutoFit/>
+          </a:bodyPr>
+          <a:lstStyle/>
           <a:p>
             <a:pPr algn="ctr">
-              <a:defRPr sz="1100" i="1">
+              <a:defRPr sz="1100" b="1">
                 <a:solidFill>
                   <a:srgbClr val="666666"/>
                 </a:solidFill>
-              </a:defRPr>
-            </a:pPr>
-            <a:r>
-              <a:t>PCA_by_sex_&lt;depot&gt;_&lt;run_tag&gt;.png</a:t>
+                <a:latin typeface="Calibri"/>
+              </a:defRPr>
+            </a:pPr>
+            <a:r>
+              <a:t>gWAT</a:t>
             </a:r>
           </a:p>
         </p:txBody>
@@ -6438,69 +6459,122 @@
           </a:p>
         </p:txBody>
       </p:sp>
-      <p:sp>
-        <p:nvSpPr>
-          <p:cNvPr id="4" name="Rectangle 3"/>
-          <p:cNvSpPr/>
+      <p:pic>
+        <p:nvPicPr>
+          <p:cNvPr id="4" name="Picture 3" descr="interaction_vs_genotype_iWAT_20260217_233911.png"/>
+          <p:cNvPicPr>
+            <a:picLocks noChangeAspect="1"/>
+          </p:cNvPicPr>
           <p:nvPr/>
-        </p:nvSpPr>
+        </p:nvPicPr>
+        <p:blipFill>
+          <a:blip r:embed="rId2"/>
+          <a:stretch>
+            <a:fillRect/>
+          </a:stretch>
+        </p:blipFill>
         <p:spPr>
           <a:xfrm>
             <a:off x="5943600" y="1097280"/>
-            <a:ext cx="5486400" cy="4572000"/>
+            <a:ext cx="2926080" cy="2468880"/>
           </a:xfrm>
           <a:prstGeom prst="rect">
             <a:avLst/>
           </a:prstGeom>
-          <a:solidFill>
-            <a:srgbClr val="F2F2F2"/>
-          </a:solidFill>
-          <a:ln w="19050">
-            <a:solidFill>
-              <a:srgbClr val="999999"/>
-            </a:solidFill>
-            <a:prstDash val="sysDash"/>
-          </a:ln>
         </p:spPr>
-        <p:style>
-          <a:lnRef idx="1">
-            <a:schemeClr val="accent1"/>
-          </a:lnRef>
-          <a:fillRef idx="3">
-            <a:schemeClr val="accent1"/>
-          </a:fillRef>
-          <a:effectRef idx="2">
-            <a:schemeClr val="accent1"/>
-          </a:effectRef>
-          <a:fontRef idx="minor">
-            <a:schemeClr val="lt1"/>
-          </a:fontRef>
-        </p:style>
-        <p:txBody>
-          <a:bodyPr rtlCol="0" anchor="ctr" wrap="square"/>
+      </p:pic>
+      <p:pic>
+        <p:nvPicPr>
+          <p:cNvPr id="5" name="Picture 4" descr="interaction_vs_genotype_gWAT_20260217_233911.png"/>
+          <p:cNvPicPr>
+            <a:picLocks noChangeAspect="1"/>
+          </p:cNvPicPr>
+          <p:nvPr/>
+        </p:nvPicPr>
+        <p:blipFill>
+          <a:blip r:embed="rId3"/>
+          <a:stretch>
+            <a:fillRect/>
+          </a:stretch>
+        </p:blipFill>
+        <p:spPr>
+          <a:xfrm>
+            <a:off x="8961120" y="1097280"/>
+            <a:ext cx="2926080" cy="2468880"/>
+          </a:xfrm>
+          <a:prstGeom prst="rect">
+            <a:avLst/>
+          </a:prstGeom>
+        </p:spPr>
+      </p:pic>
+      <p:sp>
+        <p:nvSpPr>
+          <p:cNvPr id="6" name="TextBox 5"/>
+          <p:cNvSpPr txBox="1"/>
+          <p:nvPr/>
+        </p:nvSpPr>
+        <p:spPr>
+          <a:xfrm>
+            <a:off x="6217920" y="3657600"/>
+            <a:ext cx="2286000" cy="274320"/>
+          </a:xfrm>
+          <a:prstGeom prst="rect">
+            <a:avLst/>
+          </a:prstGeom>
+          <a:noFill/>
+        </p:spPr>
+        <p:txBody>
+          <a:bodyPr wrap="square">
+            <a:spAutoFit/>
+          </a:bodyPr>
           <a:lstStyle/>
           <a:p>
             <a:pPr algn="ctr">
-              <a:defRPr sz="1400" b="1">
+              <a:defRPr sz="1100" b="1">
                 <a:solidFill>
                   <a:srgbClr val="666666"/>
                 </a:solidFill>
-              </a:defRPr>
-            </a:pPr>
-            <a:r>
-              <a:t>INSERT PLOT</a:t>
-            </a:r>
-          </a:p>
+                <a:latin typeface="Calibri"/>
+              </a:defRPr>
+            </a:pPr>
+            <a:r>
+              <a:t>iWAT</a:t>
+            </a:r>
+          </a:p>
+        </p:txBody>
+      </p:sp>
+      <p:sp>
+        <p:nvSpPr>
+          <p:cNvPr id="7" name="TextBox 6"/>
+          <p:cNvSpPr txBox="1"/>
+          <p:nvPr/>
+        </p:nvSpPr>
+        <p:spPr>
+          <a:xfrm>
+            <a:off x="9235440" y="3657600"/>
+            <a:ext cx="2286000" cy="274320"/>
+          </a:xfrm>
+          <a:prstGeom prst="rect">
+            <a:avLst/>
+          </a:prstGeom>
+          <a:noFill/>
+        </p:spPr>
+        <p:txBody>
+          <a:bodyPr wrap="square">
+            <a:spAutoFit/>
+          </a:bodyPr>
+          <a:lstStyle/>
           <a:p>
             <a:pPr algn="ctr">
-              <a:defRPr sz="1100" i="1">
+              <a:defRPr sz="1100" b="1">
                 <a:solidFill>
                   <a:srgbClr val="666666"/>
                 </a:solidFill>
-              </a:defRPr>
-            </a:pPr>
-            <a:r>
-              <a:t>interaction_vs_genotype_&lt;depot&gt;_&lt;run_tag&gt;.png</a:t>
+                <a:latin typeface="Calibri"/>
+              </a:defRPr>
+            </a:pPr>
+            <a:r>
+              <a:t>gWAT</a:t>
             </a:r>
           </a:p>
         </p:txBody>
@@ -7802,6 +7876,515 @@
 </file>
 
 <file path=ppt/slides/slide20.xml><?xml version="1.0" encoding="utf-8"?>
+<p:sld xmlns:a="http://schemas.openxmlformats.org/drawingml/2006/main" xmlns:p="http://schemas.openxmlformats.org/presentationml/2006/main" xmlns:r="http://schemas.openxmlformats.org/officeDocument/2006/relationships">
+  <p:cSld>
+    <p:spTree>
+      <p:nvGrpSpPr>
+        <p:cNvPr id="1" name=""/>
+        <p:cNvGrpSpPr/>
+        <p:nvPr/>
+      </p:nvGrpSpPr>
+      <p:grpSpPr/>
+      <p:sp>
+        <p:nvSpPr>
+          <p:cNvPr id="2" name="TextBox 1"/>
+          <p:cNvSpPr txBox="1"/>
+          <p:nvPr/>
+        </p:nvSpPr>
+        <p:spPr>
+          <a:xfrm>
+            <a:off x="548640" y="274320"/>
+            <a:ext cx="10972800" cy="548640"/>
+          </a:xfrm>
+          <a:prstGeom prst="rect">
+            <a:avLst/>
+          </a:prstGeom>
+          <a:noFill/>
+        </p:spPr>
+        <p:txBody>
+          <a:bodyPr wrap="square">
+            <a:spAutoFit/>
+          </a:bodyPr>
+          <a:lstStyle/>
+          <a:p>
+            <a:pPr algn="l">
+              <a:defRPr sz="2800" b="1">
+                <a:solidFill>
+                  <a:srgbClr val="1B3A5C"/>
+                </a:solidFill>
+                <a:latin typeface="Calibri"/>
+              </a:defRPr>
+            </a:pPr>
+            <a:r>
+              <a:t>Model Comparison: Scatter Plots (Part 7.7)</a:t>
+            </a:r>
+          </a:p>
+        </p:txBody>
+      </p:sp>
+      <p:sp>
+        <p:nvSpPr>
+          <p:cNvPr id="3" name="TextBox 2"/>
+          <p:cNvSpPr txBox="1"/>
+          <p:nvPr/>
+        </p:nvSpPr>
+        <p:spPr>
+          <a:xfrm>
+            <a:off x="548640" y="822960"/>
+            <a:ext cx="10972800" cy="365760"/>
+          </a:xfrm>
+          <a:prstGeom prst="rect">
+            <a:avLst/>
+          </a:prstGeom>
+          <a:noFill/>
+        </p:spPr>
+        <p:txBody>
+          <a:bodyPr wrap="square">
+            <a:spAutoFit/>
+          </a:bodyPr>
+          <a:lstStyle/>
+          <a:p>
+            <a:pPr algn="l">
+              <a:defRPr sz="1400" b="0">
+                <a:solidFill>
+                  <a:srgbClr val="666666"/>
+                </a:solidFill>
+                <a:latin typeface="Calibri"/>
+              </a:defRPr>
+            </a:pPr>
+            <a:r>
+              <a:t>logFC near-identity between models confirms biological conclusions are unchanged</a:t>
+            </a:r>
+          </a:p>
+        </p:txBody>
+      </p:sp>
+      <p:sp>
+        <p:nvSpPr>
+          <p:cNvPr id="4" name="TextBox 3"/>
+          <p:cNvSpPr txBox="1"/>
+          <p:nvPr/>
+        </p:nvSpPr>
+        <p:spPr>
+          <a:xfrm>
+            <a:off x="274320" y="1280160"/>
+            <a:ext cx="3657600" cy="274320"/>
+          </a:xfrm>
+          <a:prstGeom prst="rect">
+            <a:avLst/>
+          </a:prstGeom>
+          <a:noFill/>
+        </p:spPr>
+        <p:txBody>
+          <a:bodyPr wrap="square">
+            <a:spAutoFit/>
+          </a:bodyPr>
+          <a:lstStyle/>
+          <a:p>
+            <a:pPr algn="l">
+              <a:defRPr sz="1100" b="1">
+                <a:solidFill>
+                  <a:srgbClr val="1B3A5C"/>
+                </a:solidFill>
+                <a:latin typeface="Calibri"/>
+              </a:defRPr>
+            </a:pPr>
+            <a:r>
+              <a:t>3a: ~ Genotype vs ~ Sex + Genotype</a:t>
+            </a:r>
+          </a:p>
+        </p:txBody>
+      </p:sp>
+      <p:pic>
+        <p:nvPicPr>
+          <p:cNvPr id="5" name="Picture 4" descr="03a_model_comparison_sex_covariate_iWAT.png"/>
+          <p:cNvPicPr>
+            <a:picLocks noChangeAspect="1"/>
+          </p:cNvPicPr>
+          <p:nvPr/>
+        </p:nvPicPr>
+        <p:blipFill>
+          <a:blip r:embed="rId2"/>
+          <a:stretch>
+            <a:fillRect/>
+          </a:stretch>
+        </p:blipFill>
+        <p:spPr>
+          <a:xfrm>
+            <a:off x="274320" y="1554480"/>
+            <a:ext cx="3474720" cy="2286000"/>
+          </a:xfrm>
+          <a:prstGeom prst="rect">
+            <a:avLst/>
+          </a:prstGeom>
+        </p:spPr>
+      </p:pic>
+      <p:pic>
+        <p:nvPicPr>
+          <p:cNvPr id="6" name="Picture 5" descr="03a_model_comparison_sex_covariate_gWAT.png"/>
+          <p:cNvPicPr>
+            <a:picLocks noChangeAspect="1"/>
+          </p:cNvPicPr>
+          <p:nvPr/>
+        </p:nvPicPr>
+        <p:blipFill>
+          <a:blip r:embed="rId3"/>
+          <a:stretch>
+            <a:fillRect/>
+          </a:stretch>
+        </p:blipFill>
+        <p:spPr>
+          <a:xfrm>
+            <a:off x="3931920" y="1554480"/>
+            <a:ext cx="3474720" cy="2286000"/>
+          </a:xfrm>
+          <a:prstGeom prst="rect">
+            <a:avLst/>
+          </a:prstGeom>
+        </p:spPr>
+      </p:pic>
+      <p:sp>
+        <p:nvSpPr>
+          <p:cNvPr id="7" name="TextBox 6"/>
+          <p:cNvSpPr txBox="1"/>
+          <p:nvPr/>
+        </p:nvSpPr>
+        <p:spPr>
+          <a:xfrm>
+            <a:off x="274320" y="3931920"/>
+            <a:ext cx="5486400" cy="274320"/>
+          </a:xfrm>
+          <a:prstGeom prst="rect">
+            <a:avLst/>
+          </a:prstGeom>
+          <a:noFill/>
+        </p:spPr>
+        <p:txBody>
+          <a:bodyPr wrap="square">
+            <a:spAutoFit/>
+          </a:bodyPr>
+          <a:lstStyle/>
+          <a:p>
+            <a:pPr algn="l">
+              <a:defRPr sz="1100" b="1">
+                <a:solidFill>
+                  <a:srgbClr val="1B3A5C"/>
+                </a:solidFill>
+                <a:latin typeface="Calibri"/>
+              </a:defRPr>
+            </a:pPr>
+            <a:r>
+              <a:t>3c: Unified ~ 0 + GroupDepot vs ~ Sex + GroupDepot  (the key comparison)</a:t>
+            </a:r>
+          </a:p>
+        </p:txBody>
+      </p:sp>
+      <p:pic>
+        <p:nvPicPr>
+          <p:cNvPr id="8" name="Picture 7" descr="03c_nosex_vs_sex_unified_iWAT.png"/>
+          <p:cNvPicPr>
+            <a:picLocks noChangeAspect="1"/>
+          </p:cNvPicPr>
+          <p:nvPr/>
+        </p:nvPicPr>
+        <p:blipFill>
+          <a:blip r:embed="rId4"/>
+          <a:stretch>
+            <a:fillRect/>
+          </a:stretch>
+        </p:blipFill>
+        <p:spPr>
+          <a:xfrm>
+            <a:off x="274320" y="4206240"/>
+            <a:ext cx="3474720" cy="2286000"/>
+          </a:xfrm>
+          <a:prstGeom prst="rect">
+            <a:avLst/>
+          </a:prstGeom>
+        </p:spPr>
+      </p:pic>
+      <p:pic>
+        <p:nvPicPr>
+          <p:cNvPr id="9" name="Picture 8" descr="03c_nosex_vs_sex_unified_gWAT.png"/>
+          <p:cNvPicPr>
+            <a:picLocks noChangeAspect="1"/>
+          </p:cNvPicPr>
+          <p:nvPr/>
+        </p:nvPicPr>
+        <p:blipFill>
+          <a:blip r:embed="rId5"/>
+          <a:stretch>
+            <a:fillRect/>
+          </a:stretch>
+        </p:blipFill>
+        <p:spPr>
+          <a:xfrm>
+            <a:off x="3931920" y="4206240"/>
+            <a:ext cx="3474720" cy="2286000"/>
+          </a:xfrm>
+          <a:prstGeom prst="rect">
+            <a:avLst/>
+          </a:prstGeom>
+        </p:spPr>
+      </p:pic>
+      <p:sp>
+        <p:nvSpPr>
+          <p:cNvPr id="10" name="TextBox 9"/>
+          <p:cNvSpPr txBox="1"/>
+          <p:nvPr/>
+        </p:nvSpPr>
+        <p:spPr>
+          <a:xfrm>
+            <a:off x="7772400" y="1280160"/>
+            <a:ext cx="4114800" cy="274320"/>
+          </a:xfrm>
+          <a:prstGeom prst="rect">
+            <a:avLst/>
+          </a:prstGeom>
+          <a:noFill/>
+        </p:spPr>
+        <p:txBody>
+          <a:bodyPr wrap="square">
+            <a:spAutoFit/>
+          </a:bodyPr>
+          <a:lstStyle/>
+          <a:p>
+            <a:pPr algn="l">
+              <a:defRPr sz="1100" b="1">
+                <a:solidFill>
+                  <a:srgbClr val="1B3A5C"/>
+                </a:solidFill>
+                <a:latin typeface="Calibri"/>
+              </a:defRPr>
+            </a:pPr>
+            <a:r>
+              <a:t>3b: Per-depot vs Unified model</a:t>
+            </a:r>
+          </a:p>
+        </p:txBody>
+      </p:sp>
+      <p:pic>
+        <p:nvPicPr>
+          <p:cNvPr id="11" name="Picture 10" descr="03b_unified_vs_perdepot_iWAT.png"/>
+          <p:cNvPicPr>
+            <a:picLocks noChangeAspect="1"/>
+          </p:cNvPicPr>
+          <p:nvPr/>
+        </p:nvPicPr>
+        <p:blipFill>
+          <a:blip r:embed="rId6"/>
+          <a:stretch>
+            <a:fillRect/>
+          </a:stretch>
+        </p:blipFill>
+        <p:spPr>
+          <a:xfrm>
+            <a:off x="7772400" y="1554480"/>
+            <a:ext cx="2011680" cy="1554480"/>
+          </a:xfrm>
+          <a:prstGeom prst="rect">
+            <a:avLst/>
+          </a:prstGeom>
+        </p:spPr>
+      </p:pic>
+      <p:pic>
+        <p:nvPicPr>
+          <p:cNvPr id="12" name="Picture 11" descr="03b_unified_vs_perdepot_gWAT.png"/>
+          <p:cNvPicPr>
+            <a:picLocks noChangeAspect="1"/>
+          </p:cNvPicPr>
+          <p:nvPr/>
+        </p:nvPicPr>
+        <p:blipFill>
+          <a:blip r:embed="rId7"/>
+          <a:stretch>
+            <a:fillRect/>
+          </a:stretch>
+        </p:blipFill>
+        <p:spPr>
+          <a:xfrm>
+            <a:off x="9875520" y="1554480"/>
+            <a:ext cx="2011680" cy="1554480"/>
+          </a:xfrm>
+          <a:prstGeom prst="rect">
+            <a:avLst/>
+          </a:prstGeom>
+        </p:spPr>
+      </p:pic>
+      <p:sp>
+        <p:nvSpPr>
+          <p:cNvPr id="13" name="TextBox 12"/>
+          <p:cNvSpPr txBox="1"/>
+          <p:nvPr/>
+        </p:nvSpPr>
+        <p:spPr>
+          <a:xfrm>
+            <a:off x="7772400" y="3291840"/>
+            <a:ext cx="4114800" cy="3200400"/>
+          </a:xfrm>
+          <a:prstGeom prst="rect">
+            <a:avLst/>
+          </a:prstGeom>
+          <a:noFill/>
+        </p:spPr>
+        <p:txBody>
+          <a:bodyPr wrap="square">
+            <a:spAutoFit/>
+          </a:bodyPr>
+          <a:lstStyle/>
+          <a:p>
+            <a:pPr>
+              <a:spcAft>
+                <a:spcPts val="600"/>
+              </a:spcAft>
+              <a:defRPr sz="1100">
+                <a:solidFill>
+                  <a:srgbClr val="1B3A5C"/>
+                </a:solidFill>
+                <a:latin typeface="Calibri"/>
+              </a:defRPr>
+            </a:pPr>
+            <a:r>
+              <a:t>Key observations:</a:t>
+            </a:r>
+          </a:p>
+          <a:p>
+            <a:pPr>
+              <a:spcAft>
+                <a:spcPts val="600"/>
+              </a:spcAft>
+              <a:defRPr sz="1100">
+                <a:solidFill>
+                  <a:srgbClr val="1B3A5C"/>
+                </a:solidFill>
+                <a:latin typeface="Calibri"/>
+              </a:defRPr>
+            </a:pPr>
+            <a:r>
+              <a:t>  - All scatter plots cluster tightly</a:t>
+            </a:r>
+          </a:p>
+          <a:p>
+            <a:pPr>
+              <a:spcAft>
+                <a:spcPts val="600"/>
+              </a:spcAft>
+              <a:defRPr sz="1100">
+                <a:solidFill>
+                  <a:srgbClr val="1B3A5C"/>
+                </a:solidFill>
+                <a:latin typeface="Calibri"/>
+              </a:defRPr>
+            </a:pPr>
+            <a:r>
+              <a:t>    along the diagonal (y = x)</a:t>
+            </a:r>
+          </a:p>
+          <a:p>
+            <a:pPr>
+              <a:spcAft>
+                <a:spcPts val="600"/>
+              </a:spcAft>
+              <a:defRPr sz="1100">
+                <a:solidFill>
+                  <a:srgbClr val="1B3A5C"/>
+                </a:solidFill>
+                <a:latin typeface="Calibri"/>
+              </a:defRPr>
+            </a:pPr>
+            <a:r>
+              <a:t>  - Green dots = DEGs gained</a:t>
+            </a:r>
+          </a:p>
+          <a:p>
+            <a:pPr>
+              <a:spcAft>
+                <a:spcPts val="600"/>
+              </a:spcAft>
+              <a:defRPr sz="1100">
+                <a:solidFill>
+                  <a:srgbClr val="1B3A5C"/>
+                </a:solidFill>
+                <a:latin typeface="Calibri"/>
+              </a:defRPr>
+            </a:pPr>
+            <a:r>
+              <a:t>  - Red dots = DEGs lost</a:t>
+            </a:r>
+          </a:p>
+          <a:p>
+            <a:pPr>
+              <a:spcAft>
+                <a:spcPts val="600"/>
+              </a:spcAft>
+              <a:defRPr sz="1100">
+                <a:solidFill>
+                  <a:srgbClr val="1B3A5C"/>
+                </a:solidFill>
+                <a:latin typeface="Calibri"/>
+              </a:defRPr>
+            </a:pPr>
+            <a:r>
+              <a:t>  - Per-depot: adding Sex GAINS DEGs</a:t>
+            </a:r>
+          </a:p>
+          <a:p>
+            <a:pPr>
+              <a:spcAft>
+                <a:spcPts val="600"/>
+              </a:spcAft>
+              <a:defRPr sz="1100">
+                <a:solidFill>
+                  <a:srgbClr val="1B3A5C"/>
+                </a:solidFill>
+                <a:latin typeface="Calibri"/>
+              </a:defRPr>
+            </a:pPr>
+            <a:r>
+              <a:t>  - Unified: adding Sex LOSES DEGs</a:t>
+            </a:r>
+          </a:p>
+          <a:p>
+            <a:pPr>
+              <a:spcAft>
+                <a:spcPts val="600"/>
+              </a:spcAft>
+              <a:defRPr sz="1100">
+                <a:solidFill>
+                  <a:srgbClr val="1B3A5C"/>
+                </a:solidFill>
+                <a:latin typeface="Calibri"/>
+              </a:defRPr>
+            </a:pPr>
+            <a:r>
+              <a:t>  - logFC estimates nearly identical</a:t>
+            </a:r>
+          </a:p>
+          <a:p>
+            <a:pPr>
+              <a:spcAft>
+                <a:spcPts val="600"/>
+              </a:spcAft>
+              <a:defRPr sz="1100">
+                <a:solidFill>
+                  <a:srgbClr val="1B3A5C"/>
+                </a:solidFill>
+                <a:latin typeface="Calibri"/>
+              </a:defRPr>
+            </a:pPr>
+            <a:r>
+              <a:t>    regardless of model choice</a:t>
+            </a:r>
+          </a:p>
+        </p:txBody>
+      </p:sp>
+    </p:spTree>
+  </p:cSld>
+  <p:clrMapOvr>
+    <a:masterClrMapping/>
+  </p:clrMapOvr>
+</p:sld>
+</file>
+
+<file path=ppt/slides/slide21.xml><?xml version="1.0" encoding="utf-8"?>
 <p:sld xmlns:a="http://schemas.openxmlformats.org/drawingml/2006/main" xmlns:p="http://schemas.openxmlformats.org/presentationml/2006/main" xmlns:r="http://schemas.openxmlformats.org/officeDocument/2006/relationships">
   <p:cSld>
     <p:spTree>
@@ -8529,7 +9112,7 @@
 </p:sld>
 </file>
 
-<file path=ppt/slides/slide21.xml><?xml version="1.0" encoding="utf-8"?>
+<file path=ppt/slides/slide22.xml><?xml version="1.0" encoding="utf-8"?>
 <p:sld xmlns:a="http://schemas.openxmlformats.org/drawingml/2006/main" xmlns:p="http://schemas.openxmlformats.org/presentationml/2006/main" xmlns:r="http://schemas.openxmlformats.org/officeDocument/2006/relationships">
   <p:cSld>
     <p:bg>
@@ -10816,12 +11399,20 @@
           </a:p>
         </p:txBody>
       </p:sp>
-      <p:sp>
-        <p:nvSpPr>
-          <p:cNvPr id="4" name="Rectangle 3"/>
-          <p:cNvSpPr/>
+      <p:pic>
+        <p:nvPicPr>
+          <p:cNvPr id="4" name="Picture 3" descr="01_pvalue_hist_interaction_iWAT.png"/>
+          <p:cNvPicPr>
+            <a:picLocks noChangeAspect="1"/>
+          </p:cNvPicPr>
           <p:nvPr/>
-        </p:nvSpPr>
+        </p:nvPicPr>
+        <p:blipFill>
+          <a:blip r:embed="rId2"/>
+          <a:stretch>
+            <a:fillRect/>
+          </a:stretch>
+        </p:blipFill>
         <p:spPr>
           <a:xfrm>
             <a:off x="5943600" y="1097280"/>
@@ -10830,59 +11421,8 @@
           <a:prstGeom prst="rect">
             <a:avLst/>
           </a:prstGeom>
-          <a:solidFill>
-            <a:srgbClr val="F2F2F2"/>
-          </a:solidFill>
-          <a:ln w="19050">
-            <a:solidFill>
-              <a:srgbClr val="999999"/>
-            </a:solidFill>
-            <a:prstDash val="sysDash"/>
-          </a:ln>
         </p:spPr>
-        <p:style>
-          <a:lnRef idx="1">
-            <a:schemeClr val="accent1"/>
-          </a:lnRef>
-          <a:fillRef idx="3">
-            <a:schemeClr val="accent1"/>
-          </a:fillRef>
-          <a:effectRef idx="2">
-            <a:schemeClr val="accent1"/>
-          </a:effectRef>
-          <a:fontRef idx="minor">
-            <a:schemeClr val="lt1"/>
-          </a:fontRef>
-        </p:style>
-        <p:txBody>
-          <a:bodyPr rtlCol="0" anchor="ctr" wrap="square"/>
-          <a:lstStyle/>
-          <a:p>
-            <a:pPr algn="ctr">
-              <a:defRPr sz="1400" b="1">
-                <a:solidFill>
-                  <a:srgbClr val="666666"/>
-                </a:solidFill>
-              </a:defRPr>
-            </a:pPr>
-            <a:r>
-              <a:t>INSERT PLOT</a:t>
-            </a:r>
-          </a:p>
-          <a:p>
-            <a:pPr algn="ctr">
-              <a:defRPr sz="1100" i="1">
-                <a:solidFill>
-                  <a:srgbClr val="666666"/>
-                </a:solidFill>
-              </a:defRPr>
-            </a:pPr>
-            <a:r>
-              <a:t>pvalue_hist_interaction_iWAT_&lt;run_tag&gt;.png</a:t>
-            </a:r>
-          </a:p>
-        </p:txBody>
-      </p:sp>
+      </p:pic>
     </p:spTree>
   </p:cSld>
   <p:clrMapOvr>
@@ -11162,12 +11702,20 @@
           </a:p>
         </p:txBody>
       </p:sp>
-      <p:sp>
-        <p:nvSpPr>
-          <p:cNvPr id="4" name="Rectangle 3"/>
-          <p:cNvSpPr/>
+      <p:pic>
+        <p:nvPicPr>
+          <p:cNvPr id="4" name="Picture 3" descr="01_pvalue_hist_interaction_gWAT.png"/>
+          <p:cNvPicPr>
+            <a:picLocks noChangeAspect="1"/>
+          </p:cNvPicPr>
           <p:nvPr/>
-        </p:nvSpPr>
+        </p:nvPicPr>
+        <p:blipFill>
+          <a:blip r:embed="rId2"/>
+          <a:stretch>
+            <a:fillRect/>
+          </a:stretch>
+        </p:blipFill>
         <p:spPr>
           <a:xfrm>
             <a:off x="5943600" y="1097280"/>
@@ -11176,59 +11724,8 @@
           <a:prstGeom prst="rect">
             <a:avLst/>
           </a:prstGeom>
-          <a:solidFill>
-            <a:srgbClr val="F2F2F2"/>
-          </a:solidFill>
-          <a:ln w="19050">
-            <a:solidFill>
-              <a:srgbClr val="999999"/>
-            </a:solidFill>
-            <a:prstDash val="sysDash"/>
-          </a:ln>
         </p:spPr>
-        <p:style>
-          <a:lnRef idx="1">
-            <a:schemeClr val="accent1"/>
-          </a:lnRef>
-          <a:fillRef idx="3">
-            <a:schemeClr val="accent1"/>
-          </a:fillRef>
-          <a:effectRef idx="2">
-            <a:schemeClr val="accent1"/>
-          </a:effectRef>
-          <a:fontRef idx="minor">
-            <a:schemeClr val="lt1"/>
-          </a:fontRef>
-        </p:style>
-        <p:txBody>
-          <a:bodyPr rtlCol="0" anchor="ctr" wrap="square"/>
-          <a:lstStyle/>
-          <a:p>
-            <a:pPr algn="ctr">
-              <a:defRPr sz="1400" b="1">
-                <a:solidFill>
-                  <a:srgbClr val="666666"/>
-                </a:solidFill>
-              </a:defRPr>
-            </a:pPr>
-            <a:r>
-              <a:t>INSERT PLOT</a:t>
-            </a:r>
-          </a:p>
-          <a:p>
-            <a:pPr algn="ctr">
-              <a:defRPr sz="1100" i="1">
-                <a:solidFill>
-                  <a:srgbClr val="666666"/>
-                </a:solidFill>
-              </a:defRPr>
-            </a:pPr>
-            <a:r>
-              <a:t>pvalue_hist_interaction_gWAT_&lt;run_tag&gt;.png</a:t>
-            </a:r>
-          </a:p>
-        </p:txBody>
-      </p:sp>
+      </p:pic>
     </p:spTree>
   </p:cSld>
   <p:clrMapOvr>

</xml_diff>